<commit_message>
Changes to analysis and updating figures
</commit_message>
<xml_diff>
--- a/Programs/Figures/Figures.pptx
+++ b/Programs/Figures/Figures.pptx
@@ -116,14 +116,6 @@
 </p:presentation>
 </file>
 
-<file path=ppt/revisionInfo.xml><?xml version="1.0" encoding="utf-8"?>
-<p1510:revInfo xmlns:a="http://schemas.openxmlformats.org/drawingml/2006/main" xmlns:r="http://schemas.openxmlformats.org/officeDocument/2006/relationships" xmlns:p1510="http://schemas.microsoft.com/office/powerpoint/2015/10/main">
-  <p1510:revLst>
-    <p1510:client id="{EFDB26C3-1D12-4CDE-9F95-62312DB94FC3}" v="4" dt="2025-05-26T14:18:49.662"/>
-  </p1510:revLst>
-</p1510:revInfo>
-</file>
-
 <file path=ppt/changesInfos/changesInfo1.xml><?xml version="1.0" encoding="utf-8"?>
 <pc:chgInfo xmlns:a="http://schemas.openxmlformats.org/drawingml/2006/main" xmlns:r="http://schemas.openxmlformats.org/officeDocument/2006/relationships" xmlns:ac="http://schemas.microsoft.com/office/drawing/2013/main/command" xmlns:pc="http://schemas.microsoft.com/office/powerpoint/2013/main/command">
   <pc:docChgLst>
@@ -208,6 +200,94 @@
             <pc:docMk/>
             <pc:sldMk cId="343724083" sldId="259"/>
             <ac:cxnSpMk id="7" creationId="{A83506A3-BE3D-BC4E-0049-138DACF59750}"/>
+          </ac:cxnSpMkLst>
+        </pc:cxnChg>
+      </pc:sldChg>
+    </pc:docChg>
+  </pc:docChgLst>
+  <pc:docChgLst>
+    <pc:chgData name="Emma Chandler" userId="603bd503-aed1-49a7-abfb-b992e14a597c" providerId="ADAL" clId="{45B06784-8353-41A5-8240-FBF7FA2ABF4D}"/>
+    <pc:docChg chg="modSld">
+      <pc:chgData name="Emma Chandler" userId="603bd503-aed1-49a7-abfb-b992e14a597c" providerId="ADAL" clId="{45B06784-8353-41A5-8240-FBF7FA2ABF4D}" dt="2025-08-18T17:10:18.058" v="2" actId="164"/>
+      <pc:docMkLst>
+        <pc:docMk/>
+      </pc:docMkLst>
+      <pc:sldChg chg="addSp delSp modSp">
+        <pc:chgData name="Emma Chandler" userId="603bd503-aed1-49a7-abfb-b992e14a597c" providerId="ADAL" clId="{45B06784-8353-41A5-8240-FBF7FA2ABF4D}" dt="2025-08-18T17:10:18.058" v="2" actId="164"/>
+        <pc:sldMkLst>
+          <pc:docMk/>
+          <pc:sldMk cId="243415763" sldId="258"/>
+        </pc:sldMkLst>
+        <pc:spChg chg="mod topLvl">
+          <ac:chgData name="Emma Chandler" userId="603bd503-aed1-49a7-abfb-b992e14a597c" providerId="ADAL" clId="{45B06784-8353-41A5-8240-FBF7FA2ABF4D}" dt="2025-08-18T17:10:18.058" v="2" actId="164"/>
+          <ac:spMkLst>
+            <pc:docMk/>
+            <pc:sldMk cId="243415763" sldId="258"/>
+            <ac:spMk id="3" creationId="{4206A660-0557-0152-083F-705B7DD86F03}"/>
+          </ac:spMkLst>
+        </pc:spChg>
+        <pc:spChg chg="mod topLvl">
+          <ac:chgData name="Emma Chandler" userId="603bd503-aed1-49a7-abfb-b992e14a597c" providerId="ADAL" clId="{45B06784-8353-41A5-8240-FBF7FA2ABF4D}" dt="2025-08-18T17:10:18.058" v="2" actId="164"/>
+          <ac:spMkLst>
+            <pc:docMk/>
+            <pc:sldMk cId="243415763" sldId="258"/>
+            <ac:spMk id="4" creationId="{5D3EA095-57BC-041E-ED0D-29B7E31C7942}"/>
+          </ac:spMkLst>
+        </pc:spChg>
+        <pc:spChg chg="mod topLvl">
+          <ac:chgData name="Emma Chandler" userId="603bd503-aed1-49a7-abfb-b992e14a597c" providerId="ADAL" clId="{45B06784-8353-41A5-8240-FBF7FA2ABF4D}" dt="2025-08-18T17:10:18.058" v="2" actId="164"/>
+          <ac:spMkLst>
+            <pc:docMk/>
+            <pc:sldMk cId="243415763" sldId="258"/>
+            <ac:spMk id="5" creationId="{55BFF263-6A24-2F1E-2B7D-C02DEFD0C06B}"/>
+          </ac:spMkLst>
+        </pc:spChg>
+        <pc:grpChg chg="del">
+          <ac:chgData name="Emma Chandler" userId="603bd503-aed1-49a7-abfb-b992e14a597c" providerId="ADAL" clId="{45B06784-8353-41A5-8240-FBF7FA2ABF4D}" dt="2025-08-18T17:05:08.607" v="0" actId="165"/>
+          <ac:grpSpMkLst>
+            <pc:docMk/>
+            <pc:sldMk cId="243415763" sldId="258"/>
+            <ac:grpSpMk id="9" creationId="{550D8955-F202-E2A4-A493-75D4B9BAB36E}"/>
+          </ac:grpSpMkLst>
+        </pc:grpChg>
+        <pc:grpChg chg="add mod">
+          <ac:chgData name="Emma Chandler" userId="603bd503-aed1-49a7-abfb-b992e14a597c" providerId="ADAL" clId="{45B06784-8353-41A5-8240-FBF7FA2ABF4D}" dt="2025-08-18T17:10:18.058" v="2" actId="164"/>
+          <ac:grpSpMkLst>
+            <pc:docMk/>
+            <pc:sldMk cId="243415763" sldId="258"/>
+            <ac:grpSpMk id="10" creationId="{03C79DEC-7C6C-46B6-B2FE-298E1553AA35}"/>
+          </ac:grpSpMkLst>
+        </pc:grpChg>
+        <pc:picChg chg="mod topLvl">
+          <ac:chgData name="Emma Chandler" userId="603bd503-aed1-49a7-abfb-b992e14a597c" providerId="ADAL" clId="{45B06784-8353-41A5-8240-FBF7FA2ABF4D}" dt="2025-08-18T17:10:18.058" v="2" actId="164"/>
+          <ac:picMkLst>
+            <pc:docMk/>
+            <pc:sldMk cId="243415763" sldId="258"/>
+            <ac:picMk id="2" creationId="{543CD518-B6E1-FE39-4C28-E64B68B9DE2E}"/>
+          </ac:picMkLst>
+        </pc:picChg>
+        <pc:cxnChg chg="mod topLvl">
+          <ac:chgData name="Emma Chandler" userId="603bd503-aed1-49a7-abfb-b992e14a597c" providerId="ADAL" clId="{45B06784-8353-41A5-8240-FBF7FA2ABF4D}" dt="2025-08-18T17:10:18.058" v="2" actId="164"/>
+          <ac:cxnSpMkLst>
+            <pc:docMk/>
+            <pc:sldMk cId="243415763" sldId="258"/>
+            <ac:cxnSpMk id="6" creationId="{D068A658-FD63-518B-A322-816F28C5AB7A}"/>
+          </ac:cxnSpMkLst>
+        </pc:cxnChg>
+        <pc:cxnChg chg="mod topLvl">
+          <ac:chgData name="Emma Chandler" userId="603bd503-aed1-49a7-abfb-b992e14a597c" providerId="ADAL" clId="{45B06784-8353-41A5-8240-FBF7FA2ABF4D}" dt="2025-08-18T17:10:18.058" v="2" actId="164"/>
+          <ac:cxnSpMkLst>
+            <pc:docMk/>
+            <pc:sldMk cId="243415763" sldId="258"/>
+            <ac:cxnSpMk id="7" creationId="{2261C4F5-8566-07F7-3BD8-AF51947DD375}"/>
+          </ac:cxnSpMkLst>
+        </pc:cxnChg>
+        <pc:cxnChg chg="mod topLvl">
+          <ac:chgData name="Emma Chandler" userId="603bd503-aed1-49a7-abfb-b992e14a597c" providerId="ADAL" clId="{45B06784-8353-41A5-8240-FBF7FA2ABF4D}" dt="2025-08-18T17:10:18.058" v="2" actId="164"/>
+          <ac:cxnSpMkLst>
+            <pc:docMk/>
+            <pc:sldMk cId="243415763" sldId="258"/>
+            <ac:cxnSpMk id="8" creationId="{D8A980DC-1822-5665-09DF-9BEC153D33F6}"/>
           </ac:cxnSpMkLst>
         </pc:cxnChg>
       </pc:sldChg>
@@ -472,7 +552,7 @@
           <a:p>
             <a:fld id="{D8AD0DDF-2506-431C-801C-7A6D78550D5A}" type="datetimeFigureOut">
               <a:rPr lang="en-US" smtClean="0"/>
-              <a:t>5/26/2025</a:t>
+              <a:t>8/18/2025</a:t>
             </a:fld>
             <a:endParaRPr lang="en-US"/>
           </a:p>
@@ -886,7 +966,7 @@
           <a:p>
             <a:fld id="{AD0CD3B6-50D8-47DB-9864-AC89C4D06DC3}" type="datetimeFigureOut">
               <a:rPr lang="en-US" smtClean="0"/>
-              <a:t>5/26/2025</a:t>
+              <a:t>8/18/2025</a:t>
             </a:fld>
             <a:endParaRPr lang="en-US"/>
           </a:p>
@@ -1084,7 +1164,7 @@
           <a:p>
             <a:fld id="{AD0CD3B6-50D8-47DB-9864-AC89C4D06DC3}" type="datetimeFigureOut">
               <a:rPr lang="en-US" smtClean="0"/>
-              <a:t>5/26/2025</a:t>
+              <a:t>8/18/2025</a:t>
             </a:fld>
             <a:endParaRPr lang="en-US"/>
           </a:p>
@@ -1292,7 +1372,7 @@
           <a:p>
             <a:fld id="{AD0CD3B6-50D8-47DB-9864-AC89C4D06DC3}" type="datetimeFigureOut">
               <a:rPr lang="en-US" smtClean="0"/>
-              <a:t>5/26/2025</a:t>
+              <a:t>8/18/2025</a:t>
             </a:fld>
             <a:endParaRPr lang="en-US"/>
           </a:p>
@@ -1490,7 +1570,7 @@
           <a:p>
             <a:fld id="{AD0CD3B6-50D8-47DB-9864-AC89C4D06DC3}" type="datetimeFigureOut">
               <a:rPr lang="en-US" smtClean="0"/>
-              <a:t>5/26/2025</a:t>
+              <a:t>8/18/2025</a:t>
             </a:fld>
             <a:endParaRPr lang="en-US"/>
           </a:p>
@@ -1765,7 +1845,7 @@
           <a:p>
             <a:fld id="{AD0CD3B6-50D8-47DB-9864-AC89C4D06DC3}" type="datetimeFigureOut">
               <a:rPr lang="en-US" smtClean="0"/>
-              <a:t>5/26/2025</a:t>
+              <a:t>8/18/2025</a:t>
             </a:fld>
             <a:endParaRPr lang="en-US"/>
           </a:p>
@@ -2030,7 +2110,7 @@
           <a:p>
             <a:fld id="{AD0CD3B6-50D8-47DB-9864-AC89C4D06DC3}" type="datetimeFigureOut">
               <a:rPr lang="en-US" smtClean="0"/>
-              <a:t>5/26/2025</a:t>
+              <a:t>8/18/2025</a:t>
             </a:fld>
             <a:endParaRPr lang="en-US"/>
           </a:p>
@@ -2442,7 +2522,7 @@
           <a:p>
             <a:fld id="{AD0CD3B6-50D8-47DB-9864-AC89C4D06DC3}" type="datetimeFigureOut">
               <a:rPr lang="en-US" smtClean="0"/>
-              <a:t>5/26/2025</a:t>
+              <a:t>8/18/2025</a:t>
             </a:fld>
             <a:endParaRPr lang="en-US"/>
           </a:p>
@@ -2583,7 +2663,7 @@
           <a:p>
             <a:fld id="{AD0CD3B6-50D8-47DB-9864-AC89C4D06DC3}" type="datetimeFigureOut">
               <a:rPr lang="en-US" smtClean="0"/>
-              <a:t>5/26/2025</a:t>
+              <a:t>8/18/2025</a:t>
             </a:fld>
             <a:endParaRPr lang="en-US"/>
           </a:p>
@@ -2696,7 +2776,7 @@
           <a:p>
             <a:fld id="{AD0CD3B6-50D8-47DB-9864-AC89C4D06DC3}" type="datetimeFigureOut">
               <a:rPr lang="en-US" smtClean="0"/>
-              <a:t>5/26/2025</a:t>
+              <a:t>8/18/2025</a:t>
             </a:fld>
             <a:endParaRPr lang="en-US"/>
           </a:p>
@@ -3007,7 +3087,7 @@
           <a:p>
             <a:fld id="{AD0CD3B6-50D8-47DB-9864-AC89C4D06DC3}" type="datetimeFigureOut">
               <a:rPr lang="en-US" smtClean="0"/>
-              <a:t>5/26/2025</a:t>
+              <a:t>8/18/2025</a:t>
             </a:fld>
             <a:endParaRPr lang="en-US"/>
           </a:p>
@@ -3295,7 +3375,7 @@
           <a:p>
             <a:fld id="{AD0CD3B6-50D8-47DB-9864-AC89C4D06DC3}" type="datetimeFigureOut">
               <a:rPr lang="en-US" smtClean="0"/>
-              <a:t>5/26/2025</a:t>
+              <a:t>8/18/2025</a:t>
             </a:fld>
             <a:endParaRPr lang="en-US"/>
           </a:p>
@@ -3536,7 +3616,7 @@
           <a:p>
             <a:fld id="{AD0CD3B6-50D8-47DB-9864-AC89C4D06DC3}" type="datetimeFigureOut">
               <a:rPr lang="en-US" smtClean="0"/>
-              <a:t>5/26/2025</a:t>
+              <a:t>8/18/2025</a:t>
             </a:fld>
             <a:endParaRPr lang="en-US"/>
           </a:p>
@@ -3955,10 +4035,10 @@
       </p:grpSpPr>
       <p:grpSp>
         <p:nvGrpSpPr>
-          <p:cNvPr id="9" name="Group 8">
-            <a:extLst>
-              <a:ext uri="{FF2B5EF4-FFF2-40B4-BE49-F238E27FC236}">
-                <a16:creationId xmlns:a16="http://schemas.microsoft.com/office/drawing/2014/main" id="{550D8955-F202-E2A4-A493-75D4B9BAB36E}"/>
+          <p:cNvPr id="10" name="Group 9">
+            <a:extLst>
+              <a:ext uri="{FF2B5EF4-FFF2-40B4-BE49-F238E27FC236}">
+                <a16:creationId xmlns:a16="http://schemas.microsoft.com/office/drawing/2014/main" id="{03C79DEC-7C6C-46B6-B2FE-298E1553AA35}"/>
               </a:ext>
             </a:extLst>
           </p:cNvPr>
@@ -3968,9 +4048,9 @@
         <p:grpSpPr>
           <a:xfrm>
             <a:off x="945035" y="221881"/>
-            <a:ext cx="8479508" cy="6359630"/>
+            <a:ext cx="8479507" cy="6359630"/>
             <a:chOff x="945035" y="221881"/>
-            <a:chExt cx="8479508" cy="6359630"/>
+            <a:chExt cx="8479507" cy="6359630"/>
           </a:xfrm>
         </p:grpSpPr>
         <p:pic>
@@ -4001,7 +4081,7 @@
           <p:spPr bwMode="auto">
             <a:xfrm>
               <a:off x="945035" y="221881"/>
-              <a:ext cx="8479508" cy="6359630"/>
+              <a:ext cx="8479507" cy="6359630"/>
             </a:xfrm>
             <a:prstGeom prst="rect">
               <a:avLst/>

</xml_diff>